<commit_message>
Slides: say WebAssembly is usually compiler-generated in the sd-10-006 deck
Co-Authored-By: Claude Sonnet 5.5 <noreply@anthropic.com>
Claude-Session: https://claude.ai/code/session_01E4oCkXXqBf2c7oMUzFxEr2
</commit_message>
<xml_diff>
--- a/system-design-101/vi/lessons/sd-10-006/slides/sd-10-006.pptx
+++ b/system-design-101/vi/lessons/sd-10-006/slides/sd-10-006.pptx
@@ -5407,158 +5407,6 @@
         </p:nvSpPr>
         <p:spPr>
           <a:xfrm>
-            <a:off x="914400" y="4343400"/>
-            <a:ext cx="7620000" cy="1047750"/>
-          </a:xfrm>
-          <a:prstGeom prst="rect">
-            <a:avLst/>
-          </a:prstGeom>
-          <a:noFill/>
-          <a:ln/>
-        </p:spPr>
-        <p:txBody>
-          <a:bodyPr wrap="square" lIns="0" tIns="6001" rIns="0" bIns="-6001" rtlCol="0" anchor="t"/>
-          <a:lstStyle/>
-          <a:p>
-            <a:pPr algn="l" indent="0" marL="0">
-              <a:lnSpc>
-                <a:spcPts val="3780"/>
-              </a:lnSpc>
-              <a:buNone/>
-            </a:pPr>
-            <a:r>
-              <a:rPr lang="en-US" sz="2700" dirty="0" spc="2" kern="0">
-                <a:solidFill>
-                  <a:srgbClr val="C4C8D6"/>
-                </a:solidFill>
-                <a:latin typeface="Be Vietnam Pro" pitchFamily="34" charset="0"/>
-                <a:ea typeface="Be Vietnam Pro" pitchFamily="34" charset="-122"/>
-                <a:cs typeface="Be Vietnam Pro" pitchFamily="34" charset="-120"/>
-              </a:rPr>
-              <a:t>Mã</a:t>
-            </a:r>
-            <a:r>
-              <a:rPr lang="en-US" sz="2700" dirty="0" spc="-18" kern="0">
-                <a:solidFill>
-                  <a:srgbClr val="C4C8D6"/>
-                </a:solidFill>
-                <a:latin typeface="Be Vietnam Pro" pitchFamily="34" charset="0"/>
-                <a:ea typeface="Be Vietnam Pro" pitchFamily="34" charset="-122"/>
-                <a:cs typeface="Be Vietnam Pro" pitchFamily="34" charset="-120"/>
-              </a:rPr>
-              <a:t> gốc</a:t>
-            </a:r>
-            <a:r>
-              <a:rPr lang="en-US" sz="2700" dirty="0" spc="9" kern="0">
-                <a:solidFill>
-                  <a:srgbClr val="C4C8D6"/>
-                </a:solidFill>
-                <a:latin typeface="Be Vietnam Pro" pitchFamily="34" charset="0"/>
-                <a:ea typeface="Be Vietnam Pro" pitchFamily="34" charset="-122"/>
-                <a:cs typeface="Be Vietnam Pro" pitchFamily="34" charset="-120"/>
-              </a:rPr>
-              <a:t> được</a:t>
-            </a:r>
-            <a:r>
-              <a:rPr lang="en-US" sz="2700" dirty="0" spc="-3" kern="0">
-                <a:solidFill>
-                  <a:srgbClr val="C4C8D6"/>
-                </a:solidFill>
-                <a:latin typeface="Be Vietnam Pro" pitchFamily="34" charset="0"/>
-                <a:ea typeface="Be Vietnam Pro" pitchFamily="34" charset="-122"/>
-                <a:cs typeface="Be Vietnam Pro" pitchFamily="34" charset="-120"/>
-              </a:rPr>
-              <a:t> biên</a:t>
-            </a:r>
-            <a:r>
-              <a:rPr lang="en-US" sz="2700" dirty="0" spc="-1" kern="0">
-                <a:solidFill>
-                  <a:srgbClr val="C4C8D6"/>
-                </a:solidFill>
-                <a:latin typeface="Be Vietnam Pro" pitchFamily="34" charset="0"/>
-                <a:ea typeface="Be Vietnam Pro" pitchFamily="34" charset="-122"/>
-                <a:cs typeface="Be Vietnam Pro" pitchFamily="34" charset="-120"/>
-              </a:rPr>
-              <a:t> dịch</a:t>
-            </a:r>
-            <a:r>
-              <a:rPr lang="en-US" sz="2700" dirty="0" spc="-40" kern="0">
-                <a:solidFill>
-                  <a:srgbClr val="C4C8D6"/>
-                </a:solidFill>
-                <a:latin typeface="Be Vietnam Pro" pitchFamily="34" charset="0"/>
-                <a:ea typeface="Be Vietnam Pro" pitchFamily="34" charset="-122"/>
-                <a:cs typeface="Be Vietnam Pro" pitchFamily="34" charset="-120"/>
-              </a:rPr>
-              <a:t> ra</a:t>
-            </a:r>
-            <a:r>
-              <a:rPr lang="en-US" sz="2700" dirty="0" spc="0" kern="0">
-                <a:solidFill>
-                  <a:srgbClr val="C4C8D6"/>
-                </a:solidFill>
-                <a:latin typeface="Be Vietnam Pro" pitchFamily="34" charset="0"/>
-                <a:ea typeface="Be Vietnam Pro" pitchFamily="34" charset="-122"/>
-                <a:cs typeface="Be Vietnam Pro" pitchFamily="34" charset="-120"/>
-              </a:rPr>
-              <a:t> mô-đun</a:t>
-            </a:r>
-            <a:r>
-              <a:rPr lang="en-US" sz="2700" dirty="0" spc="-49" kern="0">
-                <a:solidFill>
-                  <a:srgbClr val="C4C8D6"/>
-                </a:solidFill>
-                <a:latin typeface="Be Vietnam Pro" pitchFamily="34" charset="0"/>
-                <a:ea typeface="Be Vietnam Pro" pitchFamily="34" charset="-122"/>
-                <a:cs typeface="Be Vietnam Pro" pitchFamily="34" charset="-120"/>
-              </a:rPr>
-              <a:t> WASM,</a:t>
-            </a:r>
-            <a:r>
-              <a:rPr lang="en-US" sz="2700" dirty="0" spc="-2" kern="0">
-                <a:solidFill>
-                  <a:srgbClr val="C4C8D6"/>
-                </a:solidFill>
-                <a:latin typeface="Be Vietnam Pro" pitchFamily="34" charset="0"/>
-                <a:ea typeface="Be Vietnam Pro" pitchFamily="34" charset="-122"/>
-                <a:cs typeface="Be Vietnam Pro" pitchFamily="34" charset="-120"/>
-              </a:rPr>
-              <a:t> không</a:t>
-            </a:r>
-            <a:r>
-              <a:rPr lang="en-US" sz="2700" dirty="0" spc="-5" kern="0">
-                <a:solidFill>
-                  <a:srgbClr val="C4C8D6"/>
-                </a:solidFill>
-                <a:latin typeface="Be Vietnam Pro" pitchFamily="34" charset="0"/>
-                <a:ea typeface="Be Vietnam Pro" pitchFamily="34" charset="-122"/>
-                <a:cs typeface="Be Vietnam Pro" pitchFamily="34" charset="-120"/>
-              </a:rPr>
-              <a:t> viết</a:t>
-            </a:r>
-            <a:r>
-              <a:rPr lang="en-US" sz="2700" dirty="0" spc="-20" kern="0">
-                <a:solidFill>
-                  <a:srgbClr val="C4C8D6"/>
-                </a:solidFill>
-                <a:latin typeface="Be Vietnam Pro" pitchFamily="34" charset="0"/>
-                <a:ea typeface="Be Vietnam Pro" pitchFamily="34" charset="-122"/>
-                <a:cs typeface="Be Vietnam Pro" pitchFamily="34" charset="-120"/>
-              </a:rPr>
-              <a:t> tay.</a:t>
-            </a:r>
-            <a:endParaRPr lang="en-US" sz="2700" dirty="0"/>
-          </a:p>
-        </p:txBody>
-      </p:sp>
-      <p:sp>
-        <p:nvSpPr>
-          <p:cNvPr id="6" name="Text 4"/>
-          <p:cNvSpPr/>
-          <p:nvPr/>
-        </p:nvSpPr>
-        <p:spPr>
-          <a:xfrm>
             <a:off x="914400" y="5619750"/>
             <a:ext cx="3810000" cy="685800"/>
           </a:xfrm>
@@ -5640,7 +5488,7 @@
       </p:sp>
       <p:sp>
         <p:nvSpPr>
-          <p:cNvPr id="7" name="Shape 5"/>
+          <p:cNvPr id="6" name="Shape 4"/>
           <p:cNvSpPr/>
           <p:nvPr/>
         </p:nvSpPr>
@@ -5667,7 +5515,7 @@
       </p:sp>
       <p:sp>
         <p:nvSpPr>
-          <p:cNvPr id="8" name="Text 6"/>
+          <p:cNvPr id="7" name="Text 5"/>
           <p:cNvSpPr/>
           <p:nvPr/>
         </p:nvSpPr>
@@ -5717,7 +5565,7 @@
       </p:sp>
       <p:sp>
         <p:nvSpPr>
-          <p:cNvPr id="9" name="Text 7"/>
+          <p:cNvPr id="8" name="Text 6"/>
           <p:cNvSpPr/>
           <p:nvPr/>
         </p:nvSpPr>
@@ -5869,7 +5717,7 @@
       </p:sp>
       <p:sp>
         <p:nvSpPr>
-          <p:cNvPr id="10" name="Shape 8"/>
+          <p:cNvPr id="9" name="Shape 7"/>
           <p:cNvSpPr/>
           <p:nvPr/>
         </p:nvSpPr>
@@ -5896,7 +5744,7 @@
       </p:sp>
       <p:sp>
         <p:nvSpPr>
-          <p:cNvPr id="11" name="Shape 9"/>
+          <p:cNvPr id="10" name="Shape 8"/>
           <p:cNvSpPr/>
           <p:nvPr/>
         </p:nvSpPr>
@@ -5923,7 +5771,7 @@
       </p:sp>
       <p:sp>
         <p:nvSpPr>
-          <p:cNvPr id="12" name="Text 10"/>
+          <p:cNvPr id="11" name="Text 9"/>
           <p:cNvSpPr/>
           <p:nvPr/>
         </p:nvSpPr>
@@ -5966,7 +5814,7 @@
       </p:sp>
       <p:sp>
         <p:nvSpPr>
-          <p:cNvPr id="13" name="Text 11"/>
+          <p:cNvPr id="12" name="Text 10"/>
           <p:cNvSpPr/>
           <p:nvPr/>
         </p:nvSpPr>
@@ -6038,7 +5886,7 @@
       </p:sp>
       <p:sp>
         <p:nvSpPr>
-          <p:cNvPr id="14" name="Text 12"/>
+          <p:cNvPr id="13" name="Text 11"/>
           <p:cNvSpPr/>
           <p:nvPr/>
         </p:nvSpPr>
@@ -6110,7 +5958,7 @@
       </p:sp>
       <p:sp>
         <p:nvSpPr>
-          <p:cNvPr id="15" name="Connector line-1792335438604-630118904"/>
+          <p:cNvPr id="14" name="Connector line-1792335438604-630118904"/>
           <p:cNvSpPr/>
           <p:nvPr/>
         </p:nvSpPr>
@@ -6135,7 +5983,7 @@
       </p:sp>
       <p:sp>
         <p:nvSpPr>
-          <p:cNvPr id="16" name="Shape 14"/>
+          <p:cNvPr id="15" name="Shape 13"/>
           <p:cNvSpPr/>
           <p:nvPr/>
         </p:nvSpPr>
@@ -6162,7 +6010,7 @@
       </p:sp>
       <p:sp>
         <p:nvSpPr>
-          <p:cNvPr id="17" name="Text 15"/>
+          <p:cNvPr id="16" name="Text 14"/>
           <p:cNvSpPr/>
           <p:nvPr/>
         </p:nvSpPr>
@@ -6205,7 +6053,7 @@
       </p:sp>
       <p:sp>
         <p:nvSpPr>
-          <p:cNvPr id="18" name="Text 16"/>
+          <p:cNvPr id="17" name="Text 15"/>
           <p:cNvSpPr/>
           <p:nvPr/>
         </p:nvSpPr>
@@ -6277,7 +6125,7 @@
       </p:sp>
       <p:sp>
         <p:nvSpPr>
-          <p:cNvPr id="19" name="Text 17"/>
+          <p:cNvPr id="18" name="Text 16"/>
           <p:cNvSpPr/>
           <p:nvPr/>
         </p:nvSpPr>
@@ -6338,7 +6186,7 @@
       </p:sp>
       <p:sp>
         <p:nvSpPr>
-          <p:cNvPr id="20" name="Connector line-1792335438610-810356881"/>
+          <p:cNvPr id="19" name="Connector line-1792335438610-810356881"/>
           <p:cNvSpPr/>
           <p:nvPr/>
         </p:nvSpPr>
@@ -6363,7 +6211,7 @@
       </p:sp>
       <p:sp>
         <p:nvSpPr>
-          <p:cNvPr id="21" name="Shape 19"/>
+          <p:cNvPr id="20" name="Shape 18"/>
           <p:cNvSpPr/>
           <p:nvPr/>
         </p:nvSpPr>
@@ -6390,7 +6238,7 @@
       </p:sp>
       <p:sp>
         <p:nvSpPr>
-          <p:cNvPr id="22" name="Text 20"/>
+          <p:cNvPr id="21" name="Text 19"/>
           <p:cNvSpPr/>
           <p:nvPr/>
         </p:nvSpPr>
@@ -6433,7 +6281,7 @@
       </p:sp>
       <p:sp>
         <p:nvSpPr>
-          <p:cNvPr id="23" name="Text 21"/>
+          <p:cNvPr id="22" name="Text 20"/>
           <p:cNvSpPr/>
           <p:nvPr/>
         </p:nvSpPr>
@@ -6494,7 +6342,7 @@
       </p:sp>
       <p:sp>
         <p:nvSpPr>
-          <p:cNvPr id="24" name="Text 22"/>
+          <p:cNvPr id="23" name="Text 21"/>
           <p:cNvSpPr/>
           <p:nvPr/>
         </p:nvSpPr>
@@ -6555,7 +6403,7 @@
       </p:sp>
       <p:sp>
         <p:nvSpPr>
-          <p:cNvPr id="25" name="Connector line-1792335438616-682919515"/>
+          <p:cNvPr id="24" name="Connector line-1792335438616-682919515"/>
           <p:cNvSpPr/>
           <p:nvPr/>
         </p:nvSpPr>
@@ -6580,7 +6428,7 @@
       </p:sp>
       <p:sp>
         <p:nvSpPr>
-          <p:cNvPr id="26" name="Shape 24"/>
+          <p:cNvPr id="25" name="Shape 23"/>
           <p:cNvSpPr/>
           <p:nvPr/>
         </p:nvSpPr>
@@ -6607,7 +6455,7 @@
       </p:sp>
       <p:sp>
         <p:nvSpPr>
-          <p:cNvPr id="27" name="Text 25"/>
+          <p:cNvPr id="26" name="Text 24"/>
           <p:cNvSpPr/>
           <p:nvPr/>
         </p:nvSpPr>
@@ -6650,7 +6498,7 @@
       </p:sp>
       <p:sp>
         <p:nvSpPr>
-          <p:cNvPr id="28" name="Text 26"/>
+          <p:cNvPr id="27" name="Text 25"/>
           <p:cNvSpPr/>
           <p:nvPr/>
         </p:nvSpPr>
@@ -6711,7 +6559,7 @@
       </p:sp>
       <p:sp>
         <p:nvSpPr>
-          <p:cNvPr id="29" name="Text 27"/>
+          <p:cNvPr id="28" name="Text 26"/>
           <p:cNvSpPr/>
           <p:nvPr/>
         </p:nvSpPr>
@@ -6816,7 +6664,7 @@
       </p:sp>
       <p:sp>
         <p:nvSpPr>
-          <p:cNvPr id="30" name="Shape 28"/>
+          <p:cNvPr id="29" name="Shape 27"/>
           <p:cNvSpPr/>
           <p:nvPr/>
         </p:nvSpPr>
@@ -6841,7 +6689,7 @@
       </p:sp>
       <p:sp>
         <p:nvSpPr>
-          <p:cNvPr id="31" name="Shape 29"/>
+          <p:cNvPr id="30" name="Shape 28"/>
           <p:cNvSpPr/>
           <p:nvPr/>
         </p:nvSpPr>
@@ -6866,7 +6714,7 @@
       </p:sp>
       <p:sp>
         <p:nvSpPr>
-          <p:cNvPr id="32" name="Shape 30"/>
+          <p:cNvPr id="31" name="Shape 29"/>
           <p:cNvSpPr/>
           <p:nvPr/>
         </p:nvSpPr>
@@ -6891,7 +6739,7 @@
       </p:sp>
       <p:sp>
         <p:nvSpPr>
-          <p:cNvPr id="33" name="Shape 31"/>
+          <p:cNvPr id="32" name="Shape 30"/>
           <p:cNvSpPr/>
           <p:nvPr/>
         </p:nvSpPr>
@@ -6916,7 +6764,7 @@
       </p:sp>
       <p:sp>
         <p:nvSpPr>
-          <p:cNvPr id="34" name="Shape 32"/>
+          <p:cNvPr id="33" name="Shape 31"/>
           <p:cNvSpPr/>
           <p:nvPr/>
         </p:nvSpPr>
@@ -6941,7 +6789,7 @@
       </p:sp>
       <p:sp>
         <p:nvSpPr>
-          <p:cNvPr id="35" name="Shape 33"/>
+          <p:cNvPr id="34" name="Shape 32"/>
           <p:cNvSpPr/>
           <p:nvPr/>
         </p:nvSpPr>
@@ -6966,7 +6814,7 @@
       </p:sp>
       <p:sp>
         <p:nvSpPr>
-          <p:cNvPr id="36" name="Shape 34"/>
+          <p:cNvPr id="35" name="Shape 33"/>
           <p:cNvSpPr/>
           <p:nvPr/>
         </p:nvSpPr>
@@ -6991,7 +6839,7 @@
       </p:sp>
       <p:sp>
         <p:nvSpPr>
-          <p:cNvPr id="37" name="Shape 35"/>
+          <p:cNvPr id="36" name="Shape 34"/>
           <p:cNvSpPr/>
           <p:nvPr/>
         </p:nvSpPr>
@@ -7016,7 +6864,7 @@
       </p:sp>
       <p:sp>
         <p:nvSpPr>
-          <p:cNvPr id="38" name="Shape 36"/>
+          <p:cNvPr id="37" name="Shape 35"/>
           <p:cNvSpPr/>
           <p:nvPr/>
         </p:nvSpPr>
@@ -7041,7 +6889,7 @@
       </p:sp>
       <p:sp>
         <p:nvSpPr>
-          <p:cNvPr id="39" name="Text 37"/>
+          <p:cNvPr id="38" name="Text 36"/>
           <p:cNvSpPr/>
           <p:nvPr/>
         </p:nvSpPr>
@@ -7152,6 +7000,145 @@
               <a:t> 03/09</a:t>
             </a:r>
             <a:endParaRPr lang="en-US" sz="1650" dirty="0"/>
+          </a:p>
+        </p:txBody>
+      </p:sp>
+      <p:sp>
+        <p:nvSpPr>
+          <p:cNvPr id="39" name="Text 37"/>
+          <p:cNvSpPr/>
+          <p:nvPr/>
+        </p:nvSpPr>
+        <p:spPr>
+          <a:xfrm>
+            <a:off x="914400" y="4343400"/>
+            <a:ext cx="7620000" cy="1047750"/>
+          </a:xfrm>
+          <a:prstGeom prst="rect">
+            <a:avLst/>
+          </a:prstGeom>
+          <a:noFill/>
+          <a:ln/>
+        </p:spPr>
+        <p:txBody>
+          <a:bodyPr wrap="square" lIns="0" tIns="6001" rIns="0" bIns="-6001" rtlCol="0" anchor="t"/>
+          <a:lstStyle/>
+          <a:p>
+            <a:pPr algn="l" indent="0" marL="0">
+              <a:lnSpc>
+                <a:spcPts val="3780"/>
+              </a:lnSpc>
+              <a:buNone/>
+            </a:pPr>
+            <a:r>
+              <a:rPr lang="en-US" sz="2700" dirty="0" spc="2" kern="0">
+                <a:solidFill>
+                  <a:srgbClr val="C4C8D6"/>
+                </a:solidFill>
+                <a:latin typeface="Be Vietnam Pro" pitchFamily="34" charset="0"/>
+                <a:ea typeface="Be Vietnam Pro" pitchFamily="34" charset="-122"/>
+                <a:cs typeface="Be Vietnam Pro" pitchFamily="34" charset="-120"/>
+              </a:rPr>
+              <a:t>Mã</a:t>
+            </a:r>
+            <a:r>
+              <a:rPr lang="en-US" sz="2700" dirty="0" spc="-18" kern="0">
+                <a:solidFill>
+                  <a:srgbClr val="C4C8D6"/>
+                </a:solidFill>
+                <a:latin typeface="Be Vietnam Pro" pitchFamily="34" charset="0"/>
+                <a:ea typeface="Be Vietnam Pro" pitchFamily="34" charset="-122"/>
+                <a:cs typeface="Be Vietnam Pro" pitchFamily="34" charset="-120"/>
+              </a:rPr>
+              <a:t> gốc</a:t>
+            </a:r>
+            <a:r>
+              <a:rPr lang="en-US" sz="2700" dirty="0" spc="6" kern="0">
+                <a:solidFill>
+                  <a:srgbClr val="C4C8D6"/>
+                </a:solidFill>
+                <a:latin typeface="Be Vietnam Pro" pitchFamily="34" charset="0"/>
+                <a:ea typeface="Be Vietnam Pro" pitchFamily="34" charset="-122"/>
+                <a:cs typeface="Be Vietnam Pro" pitchFamily="34" charset="-120"/>
+              </a:rPr>
+              <a:t> thường</a:t>
+            </a:r>
+            <a:r>
+              <a:rPr lang="en-US" sz="2700" dirty="0" spc="9" kern="0">
+                <a:solidFill>
+                  <a:srgbClr val="C4C8D6"/>
+                </a:solidFill>
+                <a:latin typeface="Be Vietnam Pro" pitchFamily="34" charset="0"/>
+                <a:ea typeface="Be Vietnam Pro" pitchFamily="34" charset="-122"/>
+                <a:cs typeface="Be Vietnam Pro" pitchFamily="34" charset="-120"/>
+              </a:rPr>
+              <a:t> được</a:t>
+            </a:r>
+            <a:r>
+              <a:rPr lang="en-US" sz="2700" dirty="0" spc="-3" kern="0">
+                <a:solidFill>
+                  <a:srgbClr val="C4C8D6"/>
+                </a:solidFill>
+                <a:latin typeface="Be Vietnam Pro" pitchFamily="34" charset="0"/>
+                <a:ea typeface="Be Vietnam Pro" pitchFamily="34" charset="-122"/>
+                <a:cs typeface="Be Vietnam Pro" pitchFamily="34" charset="-120"/>
+              </a:rPr>
+              <a:t> biên</a:t>
+            </a:r>
+            <a:r>
+              <a:rPr lang="en-US" sz="2700" dirty="0" spc="-1" kern="0">
+                <a:solidFill>
+                  <a:srgbClr val="C4C8D6"/>
+                </a:solidFill>
+                <a:latin typeface="Be Vietnam Pro" pitchFamily="34" charset="0"/>
+                <a:ea typeface="Be Vietnam Pro" pitchFamily="34" charset="-122"/>
+                <a:cs typeface="Be Vietnam Pro" pitchFamily="34" charset="-120"/>
+              </a:rPr>
+              <a:t> dịch</a:t>
+            </a:r>
+            <a:endParaRPr lang="en-US" sz="2700" dirty="0"/>
+          </a:p>
+          <a:p>
+            <a:pPr algn="l" indent="0" marL="0">
+              <a:lnSpc>
+                <a:spcPts val="3780"/>
+              </a:lnSpc>
+              <a:buNone/>
+            </a:pPr>
+            <a:r>
+              <a:rPr lang="en-US" sz="2700" dirty="0" spc="-58" kern="0">
+                <a:solidFill>
+                  <a:srgbClr val="C4C8D6"/>
+                </a:solidFill>
+                <a:latin typeface="Be Vietnam Pro" pitchFamily="34" charset="0"/>
+                <a:ea typeface="Be Vietnam Pro" pitchFamily="34" charset="-122"/>
+                <a:cs typeface="Be Vietnam Pro" pitchFamily="34" charset="-120"/>
+              </a:rPr>
+              <a:t>ra</a:t>
+            </a:r>
+            <a:r>
+              <a:rPr lang="en-US" sz="2700" dirty="0" spc="0" kern="0">
+                <a:solidFill>
+                  <a:srgbClr val="C4C8D6"/>
+                </a:solidFill>
+                <a:latin typeface="Be Vietnam Pro" pitchFamily="34" charset="0"/>
+                <a:ea typeface="Be Vietnam Pro" pitchFamily="34" charset="-122"/>
+                <a:cs typeface="Be Vietnam Pro" pitchFamily="34" charset="-120"/>
+              </a:rPr>
+              <a:t> mô-đun</a:t>
+            </a:r>
+            <a:r>
+              <a:rPr lang="en-US" sz="2700" dirty="0" spc="-50" kern="0">
+                <a:solidFill>
+                  <a:srgbClr val="C4C8D6"/>
+                </a:solidFill>
+                <a:latin typeface="Be Vietnam Pro" pitchFamily="34" charset="0"/>
+                <a:ea typeface="Be Vietnam Pro" pitchFamily="34" charset="-122"/>
+                <a:cs typeface="Be Vietnam Pro" pitchFamily="34" charset="-120"/>
+              </a:rPr>
+              <a:t> WASM.</a:t>
+            </a:r>
+            <a:endParaRPr lang="en-US" sz="2700" dirty="0"/>
           </a:p>
         </p:txBody>
       </p:sp>
@@ -14371,7 +14358,203 @@
       </p:sp>
       <p:sp>
         <p:nvSpPr>
-          <p:cNvPr id="35" name="Shape 33"/>
+          <p:cNvPr id="35" name="Text 33"/>
+          <p:cNvSpPr/>
+          <p:nvPr/>
+        </p:nvSpPr>
+        <p:spPr>
+          <a:xfrm>
+            <a:off x="914400" y="5676900"/>
+            <a:ext cx="7620000" cy="762000"/>
+          </a:xfrm>
+          <a:prstGeom prst="rect">
+            <a:avLst/>
+          </a:prstGeom>
+          <a:noFill/>
+          <a:ln/>
+        </p:spPr>
+        <p:txBody>
+          <a:bodyPr wrap="square" lIns="0" tIns="4667" rIns="0" bIns="-4667" rtlCol="0" anchor="t"/>
+          <a:lstStyle/>
+          <a:p>
+            <a:pPr algn="l" indent="0" marL="0">
+              <a:lnSpc>
+                <a:spcPts val="2940"/>
+              </a:lnSpc>
+              <a:buNone/>
+            </a:pPr>
+            <a:r>
+              <a:rPr lang="en-US" sz="2100" dirty="0" spc="-59" kern="0">
+                <a:solidFill>
+                  <a:srgbClr val="C4C8D6"/>
+                </a:solidFill>
+                <a:latin typeface="Be Vietnam Pro" pitchFamily="34" charset="0"/>
+                <a:ea typeface="Be Vietnam Pro" pitchFamily="34" charset="-122"/>
+                <a:cs typeface="Be Vietnam Pro" pitchFamily="34" charset="-120"/>
+              </a:rPr>
+              <a:t>WASM</a:t>
+            </a:r>
+            <a:r>
+              <a:rPr lang="en-US" sz="2100" dirty="0" spc="-4" kern="0">
+                <a:solidFill>
+                  <a:srgbClr val="C4C8D6"/>
+                </a:solidFill>
+                <a:latin typeface="Be Vietnam Pro" pitchFamily="34" charset="0"/>
+                <a:ea typeface="Be Vietnam Pro" pitchFamily="34" charset="-122"/>
+                <a:cs typeface="Be Vietnam Pro" pitchFamily="34" charset="-120"/>
+              </a:rPr>
+              <a:t> có</a:t>
+            </a:r>
+            <a:r>
+              <a:rPr lang="en-US" sz="2100" dirty="0" spc="-2" kern="0">
+                <a:solidFill>
+                  <a:srgbClr val="C4C8D6"/>
+                </a:solidFill>
+                <a:latin typeface="Be Vietnam Pro" pitchFamily="34" charset="0"/>
+                <a:ea typeface="Be Vietnam Pro" pitchFamily="34" charset="-122"/>
+                <a:cs typeface="Be Vietnam Pro" pitchFamily="34" charset="-120"/>
+              </a:rPr>
+              <a:t> dạng</a:t>
+            </a:r>
+            <a:r>
+              <a:rPr lang="en-US" sz="2100" dirty="0" spc="-13" kern="0">
+                <a:solidFill>
+                  <a:srgbClr val="C4C8D6"/>
+                </a:solidFill>
+                <a:latin typeface="Be Vietnam Pro" pitchFamily="34" charset="0"/>
+                <a:ea typeface="Be Vietnam Pro" pitchFamily="34" charset="-122"/>
+                <a:cs typeface="Be Vietnam Pro" pitchFamily="34" charset="-120"/>
+              </a:rPr>
+              <a:t> văn</a:t>
+            </a:r>
+            <a:r>
+              <a:rPr lang="en-US" sz="2100" dirty="0" spc="-5" kern="0">
+                <a:solidFill>
+                  <a:srgbClr val="C4C8D6"/>
+                </a:solidFill>
+                <a:latin typeface="Be Vietnam Pro" pitchFamily="34" charset="0"/>
+                <a:ea typeface="Be Vietnam Pro" pitchFamily="34" charset="-122"/>
+                <a:cs typeface="Be Vietnam Pro" pitchFamily="34" charset="-120"/>
+              </a:rPr>
+              <a:t> bản</a:t>
+            </a:r>
+            <a:r>
+              <a:rPr lang="en-US" sz="2100" dirty="0" spc="6" kern="0">
+                <a:solidFill>
+                  <a:srgbClr val="C4C8D6"/>
+                </a:solidFill>
+                <a:latin typeface="Be Vietnam Pro" pitchFamily="34" charset="0"/>
+                <a:ea typeface="Be Vietnam Pro" pitchFamily="34" charset="-122"/>
+                <a:cs typeface="Be Vietnam Pro" pitchFamily="34" charset="-120"/>
+              </a:rPr>
+              <a:t> đọc</a:t>
+            </a:r>
+            <a:r>
+              <a:rPr lang="en-US" sz="2100" dirty="0" spc="3" kern="0">
+                <a:solidFill>
+                  <a:srgbClr val="C4C8D6"/>
+                </a:solidFill>
+                <a:latin typeface="Be Vietnam Pro" pitchFamily="34" charset="0"/>
+                <a:ea typeface="Be Vietnam Pro" pitchFamily="34" charset="-122"/>
+                <a:cs typeface="Be Vietnam Pro" pitchFamily="34" charset="-120"/>
+              </a:rPr>
+              <a:t> được,</a:t>
+            </a:r>
+            <a:r>
+              <a:rPr lang="en-US" sz="2100" dirty="0" spc="14" kern="0">
+                <a:solidFill>
+                  <a:srgbClr val="C4C8D6"/>
+                </a:solidFill>
+                <a:latin typeface="Be Vietnam Pro" pitchFamily="34" charset="0"/>
+                <a:ea typeface="Be Vietnam Pro" pitchFamily="34" charset="-122"/>
+                <a:cs typeface="Be Vietnam Pro" pitchFamily="34" charset="-120"/>
+              </a:rPr>
+              <a:t> nhưng</a:t>
+            </a:r>
+            <a:r>
+              <a:rPr lang="en-US" sz="2100" dirty="0" spc="3" kern="0">
+                <a:solidFill>
+                  <a:srgbClr val="C4C8D6"/>
+                </a:solidFill>
+                <a:latin typeface="Be Vietnam Pro" pitchFamily="34" charset="0"/>
+                <a:ea typeface="Be Vietnam Pro" pitchFamily="34" charset="-122"/>
+                <a:cs typeface="Be Vietnam Pro" pitchFamily="34" charset="-120"/>
+              </a:rPr>
+              <a:t> thường</a:t>
+            </a:r>
+            <a:r>
+              <a:rPr lang="en-US" sz="2100" dirty="0" spc="-4" kern="0">
+                <a:solidFill>
+                  <a:srgbClr val="C4C8D6"/>
+                </a:solidFill>
+                <a:latin typeface="Be Vietnam Pro" pitchFamily="34" charset="0"/>
+                <a:ea typeface="Be Vietnam Pro" pitchFamily="34" charset="-122"/>
+                <a:cs typeface="Be Vietnam Pro" pitchFamily="34" charset="-120"/>
+              </a:rPr>
+              <a:t> do</a:t>
+            </a:r>
+            <a:r>
+              <a:rPr lang="en-US" sz="2100" dirty="0" spc="7" kern="0">
+                <a:solidFill>
+                  <a:srgbClr val="C4C8D6"/>
+                </a:solidFill>
+                <a:latin typeface="Be Vietnam Pro" pitchFamily="34" charset="0"/>
+                <a:ea typeface="Be Vietnam Pro" pitchFamily="34" charset="-122"/>
+                <a:cs typeface="Be Vietnam Pro" pitchFamily="34" charset="-120"/>
+              </a:rPr>
+              <a:t> trình</a:t>
+            </a:r>
+            <a:r>
+              <a:rPr lang="en-US" sz="2100" dirty="0" spc="0" kern="0">
+                <a:solidFill>
+                  <a:srgbClr val="C4C8D6"/>
+                </a:solidFill>
+                <a:latin typeface="Be Vietnam Pro" pitchFamily="34" charset="0"/>
+                <a:ea typeface="Be Vietnam Pro" pitchFamily="34" charset="-122"/>
+                <a:cs typeface="Be Vietnam Pro" pitchFamily="34" charset="-120"/>
+              </a:rPr>
+              <a:t> biên</a:t>
+            </a:r>
+            <a:r>
+              <a:rPr lang="en-US" sz="2100" dirty="0" spc="-1" kern="0">
+                <a:solidFill>
+                  <a:srgbClr val="C4C8D6"/>
+                </a:solidFill>
+                <a:latin typeface="Be Vietnam Pro" pitchFamily="34" charset="0"/>
+                <a:ea typeface="Be Vietnam Pro" pitchFamily="34" charset="-122"/>
+                <a:cs typeface="Be Vietnam Pro" pitchFamily="34" charset="-120"/>
+              </a:rPr>
+              <a:t> dịch</a:t>
+            </a:r>
+            <a:r>
+              <a:rPr lang="en-US" sz="2100" dirty="0" spc="-14" kern="0">
+                <a:solidFill>
+                  <a:srgbClr val="C4C8D6"/>
+                </a:solidFill>
+                <a:latin typeface="Be Vietnam Pro" pitchFamily="34" charset="0"/>
+                <a:ea typeface="Be Vietnam Pro" pitchFamily="34" charset="-122"/>
+                <a:cs typeface="Be Vietnam Pro" pitchFamily="34" charset="-120"/>
+              </a:rPr>
+              <a:t> tạo</a:t>
+            </a:r>
+            <a:r>
+              <a:rPr lang="en-US" sz="2100" dirty="0" spc="-22" kern="0">
+                <a:solidFill>
+                  <a:srgbClr val="C4C8D6"/>
+                </a:solidFill>
+                <a:latin typeface="Be Vietnam Pro" pitchFamily="34" charset="0"/>
+                <a:ea typeface="Be Vietnam Pro" pitchFamily="34" charset="-122"/>
+                <a:cs typeface="Be Vietnam Pro" pitchFamily="34" charset="-120"/>
+              </a:rPr>
+              <a:t> ra.</a:t>
+            </a:r>
+            <a:endParaRPr lang="en-US" sz="2100" dirty="0"/>
+          </a:p>
+        </p:txBody>
+      </p:sp>
+      <p:sp>
+        <p:nvSpPr>
+          <p:cNvPr id="36" name="Shape 34"/>
           <p:cNvSpPr/>
           <p:nvPr/>
         </p:nvSpPr>
@@ -14395,7 +14578,7 @@
       </p:sp>
       <p:pic>
         <p:nvPicPr>
-          <p:cNvPr id="36" name="Moda image moda-export-watermark-cd59b3fe-3cb3-40e1-a95a-6d4beaabb8da" descr="">    </p:cNvPr>
+          <p:cNvPr id="37" name="Moda image moda-export-watermark-cd59b3fe-3cb3-40e1-a95a-6d4beaabb8da" descr="">    </p:cNvPr>
           <p:cNvPicPr>
             <a:picLocks noChangeAspect="1"/>
           </p:cNvPicPr>

</xml_diff>